<commit_message>
results: publish the complete three-solver main ladder and final PART IV slides
main_full finished with 45/45 fits (SMO, ADMM, PA-ADMM), correctness was rerun
under the aligned adaptive-rho configuration so all three solvers now certify on
the same 7,000-row QP (spread 7.7e-5), and the tables, report figures, deck and
generated summary are rebuilt from that state.

Per the protocol decision, SMO keeps its default 100,000-update cap: it exhausts
the cap in 15/15 full-data fits ~1.6% above the group-best objective, which the
slides and EXPERIMENTS.md report as a scalability limit rather than a timeout.
</commit_message>
<xml_diff>
--- a/slides/COMP6704_Group4_PART_IV.pptx
+++ b/slides/COMP6704_Group4_PART_IV.pptx
@@ -39694,7 +39694,7 @@
                 </a:solidFill>
                 <a:latin typeface="Calibri"/>
               </a:rPr>
-              <a:t>Generated 2026-10-27 01:47 from 102 recorded fits · results shown for ADMM, PA-ADMM, SMO · still pending: CVXPY, Pegasos</a:t>
+              <a:t>Generated 2026-10-27 10:11 from 102 recorded fits · results shown for ADMM, PA-ADMM, SMO · still pending: CVXPY, Pegasos</a:t>
             </a:r>
           </a:p>
         </p:txBody>
@@ -42533,7 +42533,7 @@
                 </a:solidFill>
                 <a:latin typeface="Calibri"/>
               </a:rPr>
-              <a:t>At 20:1 on the full data, median time-to-tolerance: SMO n/as, ADMM 43s, PA-ADMM 49s. Final fit time is dominated by iterating past the tolerance line until the solver's own certificate (KKT / residual + duality gap) is satisfied.</a:t>
+              <a:t>At 20:1 on the full data, median time-to-tolerance: ADMM 43s, PA-ADMM 49s. SMO never reached the tolerance at 20:1. Final fit time is dominated by iterating past the tolerance line until the solver's own certificate (KKT / residual + duality gap) is satisfied.</a:t>
             </a:r>
           </a:p>
           <a:p>
@@ -42545,7 +42545,7 @@
                 </a:solidFill>
                 <a:latin typeface="Calibri"/>
               </a:rPr>
-              <a:t>Right panel counts certified seeds at the hardest ratio 50:1 → ADMM 0/5, PA-ADMM 3/5, SMO 0/5. Pushing Cᵢ higher makes the QP stiffer; PA-ADMM certifies the most seeds there. SMO exhausted its own 100,000-update limit on 15 of 15 main_full fits after 1393s of a 5400s budget (7/9 already at 35k): that 'not converged' flag is an iteration-cap outcome, not a wall-clock timeout.</a:t>
+              <a:t>Right panel counts certified seeds at the hardest ratio 50:1 → ADMM 0/5, PA-ADMM 3/5, SMO 0/5. Pushing Cᵢ higher makes the QP stiffer; PA-ADMM certifies the most seeds there. SMO exhausted its own 100,000-update limit on 15 of 15 main_full fits after 1393s of a 5400s budget (7/9 already at 35k), finishing 1.6% above the group-best objective. We keep its default cap and report this as a scalability limit of SMO under this protocol, not a wall-clock timeout.</a:t>
             </a:r>
           </a:p>
         </p:txBody>

</xml_diff>

<commit_message>
results: finalize the main ladder and rebuild the PART IV slides
</commit_message>
<xml_diff>
--- a/slides/COMP6704_Group4_PART_IV.pptx
+++ b/slides/COMP6704_Group4_PART_IV.pptx
@@ -39694,7 +39694,7 @@
                 </a:solidFill>
                 <a:latin typeface="Calibri"/>
               </a:rPr>
-              <a:t>Generated 2026-10-27 10:11 from 102 recorded fits · results shown for ADMM, PA-ADMM, SMO · still pending: CVXPY, Pegasos</a:t>
+              <a:t>Generated 2026-10-27 11:00 from 105 recorded fits · results shown for ADMM, PA-ADMM, Pegasos, SMO</a:t>
             </a:r>
           </a:p>
         </p:txBody>
@@ -41209,6 +41209,18 @@
                 </a:solidFill>
                 <a:latin typeface="Calibri"/>
               </a:rPr>
+              <a:t>Pegasos   P = 10.3852   not certified   (550,000 updates/iterations)</a:t>
+            </a:r>
+          </a:p>
+          <a:p>
+            <a:pPr algn="l"/>
+            <a:r>
+              <a:rPr sz="1250" b="0">
+                <a:solidFill>
+                  <a:srgbClr val="182B3A"/>
+                </a:solidFill>
+                <a:latin typeface="Calibri"/>
+              </a:rPr>
               <a:t>ADMM      P = 5.0836   certified   (7,525 updates/iterations)</a:t>
             </a:r>
           </a:p>
@@ -41257,6 +41269,30 @@
                 <a:latin typeface="Calibri"/>
               </a:rPr>
               <a:t>One 10k stratified subset (7,000 train / 1,500 val / 1,500 test), C fixed to 1, ratio 10:1, tolerance 1e-4. WP2 also checks SMO against LIBSVM and WP3 checks ADMM against CVXPY/ECOS on identical rows.</a:t>
+            </a:r>
+          </a:p>
+          <a:p>
+            <a:pPr algn="l"/>
+            <a:r>
+              <a:rPr sz="1250" b="0">
+                <a:solidFill>
+                  <a:srgbClr val="526574"/>
+                </a:solidFill>
+                <a:latin typeface="Calibri"/>
+              </a:rPr>
+              <a:t/>
+            </a:r>
+          </a:p>
+          <a:p>
+            <a:pPr algn="l"/>
+            <a:r>
+              <a:rPr sz="1250" b="0">
+                <a:solidFill>
+                  <a:srgbClr val="526574"/>
+                </a:solidFill>
+                <a:latin typeface="Calibri"/>
+              </a:rPr>
+              <a:t>Pegasos did not certify in this configuration (cold fixed-ρ, 10,000-iteration cap) and is reported as unconverged rather than smoothed away.</a:t>
             </a:r>
           </a:p>
         </p:txBody>
@@ -41494,7 +41530,7 @@
                 </a:solidFill>
                 <a:latin typeface="Calibri"/>
               </a:rPr>
-              <a:t>methods with committed results: ADMM, PA-ADMM, SMO · pending: CVXPY, Pegasos</a:t>
+              <a:t>methods with committed results: ADMM, PA-ADMM, Pegasos, SMO</a:t>
             </a:r>
           </a:p>
         </p:txBody>
@@ -42201,7 +42237,7 @@
                 </a:solidFill>
                 <a:latin typeface="Calibri"/>
               </a:rPr>
-              <a:t>Pegasos and the CVXPY baseline are still pending; their cells are reported as skipped, not imputed.</a:t>
+              <a:t>All registered methods completed.</a:t>
             </a:r>
           </a:p>
         </p:txBody>
@@ -45702,7 +45738,7 @@
                 </a:solidFill>
                 <a:latin typeface="Calibri"/>
               </a:rPr>
-              <a:t>102 fits are recorded so far; pending: CVXPY, Pegasos. The capped-subset quality bars rest on a handful of test frauds, and all timings come from one single-threaded machine.</a:t>
+              <a:t>105 fits are recorded so far; pending: none. The capped-subset quality bars rest on a handful of test frauds, and all timings come from one single-threaded machine.</a:t>
             </a:r>
           </a:p>
         </p:txBody>

</xml_diff>